<commit_message>
Complete typography across conversion routes
</commit_message>
<xml_diff>
--- a/Website/Apps/OfficeIMO.Web.Converter/wwwroot/samples/conversion-proof.pptx
+++ b/Website/Apps/OfficeIMO.Web.Converter/wwwroot/samples/conversion-proof.pptx
@@ -5,7 +5,7 @@
     <p:sldMasterId xmlns:r="http://schemas.openxmlformats.org/officeDocument/2006/relationships" id="2147483648" r:id="rId1"/>
   </p:sldMasterIdLst>
   <p:notesMasterIdLst>
-    <p:notesMasterId xmlns:r="http://schemas.openxmlformats.org/officeDocument/2006/relationships" r:id="Rd4a14ac6915643f1"/>
+    <p:notesMasterId xmlns:r="http://schemas.openxmlformats.org/officeDocument/2006/relationships" r:id="Rc8025739975a426b"/>
   </p:notesMasterIdLst>
   <p:sldIdLst>
     <p:sldId xmlns:r="http://schemas.openxmlformats.org/officeDocument/2006/relationships" id="256" r:id="rId2"/>
@@ -217,7 +217,7 @@
     <c:dispBlanksAs val="gap"/>
     <c:showDLblsOverMax val="0"/>
   </c:chart>
-  <c:externalData r:id="Rdca4b051a5fd441f">
+  <c:externalData r:id="Rdecfcbad0a6d461e">
     <c:autoUpdate val="0"/>
   </c:externalData>
 </c:chartSpace>
@@ -2926,7 +2926,7 @@
         </p:xfrm>
         <a:graphic xmlns:a="http://schemas.openxmlformats.org/drawingml/2006/main">
           <a:graphicData uri="http://schemas.openxmlformats.org/drawingml/2006/chart">
-            <c:chart xmlns:r="http://schemas.openxmlformats.org/officeDocument/2006/relationships" xmlns:c="http://schemas.openxmlformats.org/drawingml/2006/chart" r:id="R0682a1ff74da4a9d"/>
+            <c:chart xmlns:r="http://schemas.openxmlformats.org/officeDocument/2006/relationships" xmlns:c="http://schemas.openxmlformats.org/drawingml/2006/chart" r:id="Rb1272a9c28bf4c6d"/>
           </a:graphicData>
         </a:graphic>
       </p:graphicFrame>

</xml_diff>

<commit_message>
Unify document conversion and PDF APIs
</commit_message>
<xml_diff>
--- a/Website/Apps/OfficeIMO.Web.Converter/wwwroot/samples/conversion-proof.pptx
+++ b/Website/Apps/OfficeIMO.Web.Converter/wwwroot/samples/conversion-proof.pptx
@@ -5,7 +5,7 @@
     <p:sldMasterId xmlns:r="http://schemas.openxmlformats.org/officeDocument/2006/relationships" id="2147483648" r:id="rId1"/>
   </p:sldMasterIdLst>
   <p:notesMasterIdLst>
-    <p:notesMasterId xmlns:r="http://schemas.openxmlformats.org/officeDocument/2006/relationships" r:id="Rc8025739975a426b"/>
+    <p:notesMasterId xmlns:r="http://schemas.openxmlformats.org/officeDocument/2006/relationships" r:id="Rc02d272637e94eba"/>
   </p:notesMasterIdLst>
   <p:sldIdLst>
     <p:sldId xmlns:r="http://schemas.openxmlformats.org/officeDocument/2006/relationships" id="256" r:id="rId2"/>
@@ -217,7 +217,7 @@
     <c:dispBlanksAs val="gap"/>
     <c:showDLblsOverMax val="0"/>
   </c:chart>
-  <c:externalData r:id="Rdecfcbad0a6d461e">
+  <c:externalData r:id="Rb54e650b39634bfe">
     <c:autoUpdate val="0"/>
   </c:externalData>
 </c:chartSpace>
@@ -2926,7 +2926,7 @@
         </p:xfrm>
         <a:graphic xmlns:a="http://schemas.openxmlformats.org/drawingml/2006/main">
           <a:graphicData uri="http://schemas.openxmlformats.org/drawingml/2006/chart">
-            <c:chart xmlns:r="http://schemas.openxmlformats.org/officeDocument/2006/relationships" xmlns:c="http://schemas.openxmlformats.org/drawingml/2006/chart" r:id="Rb1272a9c28bf4c6d"/>
+            <c:chart xmlns:r="http://schemas.openxmlformats.org/officeDocument/2006/relationships" xmlns:c="http://schemas.openxmlformats.org/drawingml/2006/chart" r:id="Rc5deac4b221c4ebd"/>
           </a:graphicData>
         </a:graphic>
       </p:graphicFrame>

</xml_diff>